<commit_message>
docs(ppt): add presentation script and update AWS challenge draft deck
Co-Authored-By: Claude Sonnet 5.5 <noreply@anthropic.com>
</commit_message>
<xml_diff>
--- a/ppt/JIVA-AWS-Innovation-Challenge-2026-DRAFT.pptx
+++ b/ppt/JIVA-AWS-Innovation-Challenge-2026-DRAFT.pptx
@@ -316,6 +316,11 @@
       </a:defRPr>
     </a:lvl9pPr>
   </p:defaultTextStyle>
+  <p:extLst>
+    <p:ext uri="{EFAFB233-063F-42B5-8137-9DF3F51BA10A}">
+      <p15:sldGuideLst xmlns:p15="http://schemas.microsoft.com/office/powerpoint/2012/main"/>
+    </p:ext>
+  </p:extLst>
 </p:presentation>
 </file>
 
@@ -475,6 +480,72 @@
 </p:notesMaster>
 </file>
 
+<file path=ppt/notesSlides/notesSlide1.xml><?xml version="1.0" encoding="utf-8"?>
+<p:notes xmlns:a="http://schemas.openxmlformats.org/drawingml/2006/main" xmlns:r="http://schemas.openxmlformats.org/officeDocument/2006/relationships" xmlns:p="http://schemas.openxmlformats.org/presentationml/2006/main">
+  <p:cSld>
+    <p:spTree>
+      <p:nvGrpSpPr>
+        <p:cNvPr id="1" name=""/>
+        <p:cNvGrpSpPr/>
+        <p:nvPr/>
+      </p:nvGrpSpPr>
+      <p:grpSpPr>
+        <a:xfrm>
+          <a:off x="0" y="0"/>
+          <a:ext cx="0" cy="0"/>
+          <a:chOff x="0" y="0"/>
+          <a:chExt cx="0" cy="0"/>
+        </a:xfrm>
+      </p:grpSpPr>
+      <p:sp>
+        <p:nvSpPr>
+          <p:cNvPr id="2" name="Slide Image Placeholder 1"/>
+          <p:cNvSpPr>
+            <a:spLocks noGrp="1" noRot="1" noChangeAspect="1"/>
+          </p:cNvSpPr>
+          <p:nvPr>
+            <p:ph type="sldImg"/>
+          </p:nvPr>
+        </p:nvSpPr>
+        <p:spPr>
+          <a:xfrm>
+            <a:off x="381000" y="685800"/>
+            <a:ext cx="6096000" cy="3429000"/>
+          </a:xfrm>
+        </p:spPr>
+      </p:sp>
+      <p:sp>
+        <p:nvSpPr>
+          <p:cNvPr id="3" name="Notes Placeholder 2"/>
+          <p:cNvSpPr>
+            <a:spLocks noGrp="1"/>
+          </p:cNvSpPr>
+          <p:nvPr>
+            <p:ph type="body" idx="1"/>
+          </p:nvPr>
+        </p:nvSpPr>
+        <p:spPr/>
+        <p:txBody>
+          <a:bodyPr/>
+          <a:lstStyle/>
+          <a:p>
+            <a:endParaRPr lang="en-IN" dirty="0"/>
+          </a:p>
+        </p:txBody>
+      </p:sp>
+    </p:spTree>
+    <p:extLst>
+      <p:ext uri="{BB962C8B-B14F-4D97-AF65-F5344CB8AC3E}">
+        <p14:creationId xmlns:p14="http://schemas.microsoft.com/office/powerpoint/2010/main" val="1987313289"/>
+      </p:ext>
+    </p:extLst>
+  </p:cSld>
+  <p:clrMapOvr>
+    <a:masterClrMapping/>
+  </p:clrMapOvr>
+</p:notes>
+</file>
+
 <file path=ppt/slideLayouts/slideLayout1.xml><?xml version="1.0" encoding="utf-8"?>
 <p:sldLayout xmlns:a="http://schemas.openxmlformats.org/drawingml/2006/main" xmlns:r="http://schemas.openxmlformats.org/officeDocument/2006/relationships" xmlns:p="http://schemas.openxmlformats.org/presentationml/2006/main" type="tx">
   <p:cSld name="DEFAULT">
@@ -575,7 +646,7 @@
           </a:ln>
           <a:extLst>
             <a:ext uri="{C572A759-6A51-4108-AA02-DFA0A04FC94B}">
-              <ma14:wrappingTextBoxFlag xmlns:ma14="http://schemas.microsoft.com/office/mac/drawingml/2011/main" xmlns:a14="http://schemas.microsoft.com/office/drawing/2010/main" xmlns:m="http://schemas.openxmlformats.org/officeDocument/2006/math" xmlns="" val="1"/>
+              <ma14:wrappingTextBoxFlag xmlns="" xmlns:m="http://schemas.openxmlformats.org/officeDocument/2006/math" xmlns:a14="http://schemas.microsoft.com/office/drawing/2010/main" xmlns:ma14="http://schemas.microsoft.com/office/mac/drawingml/2011/main" val="1"/>
             </a:ext>
           </a:extLst>
         </p:spPr>
@@ -612,7 +683,7 @@
           </a:ln>
           <a:extLst>
             <a:ext uri="{C572A759-6A51-4108-AA02-DFA0A04FC94B}">
-              <ma14:wrappingTextBoxFlag xmlns:ma14="http://schemas.microsoft.com/office/mac/drawingml/2011/main" xmlns:a14="http://schemas.microsoft.com/office/drawing/2010/main" xmlns:m="http://schemas.openxmlformats.org/officeDocument/2006/math" xmlns="" val="1"/>
+              <ma14:wrappingTextBoxFlag xmlns="" xmlns:m="http://schemas.openxmlformats.org/officeDocument/2006/math" xmlns:a14="http://schemas.microsoft.com/office/drawing/2010/main" xmlns:ma14="http://schemas.microsoft.com/office/mac/drawingml/2011/main" val="1"/>
             </a:ext>
           </a:extLst>
         </p:spPr>
@@ -1532,7 +1603,7 @@
           </a:ln>
           <a:extLst>
             <a:ext uri="{C572A759-6A51-4108-AA02-DFA0A04FC94B}">
-              <ma14:wrappingTextBoxFlag xmlns:ma14="http://schemas.microsoft.com/office/mac/drawingml/2011/main" xmlns:a14="http://schemas.microsoft.com/office/drawing/2010/main" xmlns:m="http://schemas.openxmlformats.org/officeDocument/2006/math" xmlns="" val="1"/>
+              <ma14:wrappingTextBoxFlag xmlns="" xmlns:m="http://schemas.openxmlformats.org/officeDocument/2006/math" xmlns:a14="http://schemas.microsoft.com/office/drawing/2010/main" xmlns:ma14="http://schemas.microsoft.com/office/mac/drawingml/2011/main" val="1"/>
             </a:ext>
           </a:extLst>
         </p:spPr>
@@ -1575,7 +1646,7 @@
           </a:ln>
           <a:extLst>
             <a:ext uri="{C572A759-6A51-4108-AA02-DFA0A04FC94B}">
-              <ma14:wrappingTextBoxFlag xmlns:ma14="http://schemas.microsoft.com/office/mac/drawingml/2011/main" xmlns:a14="http://schemas.microsoft.com/office/drawing/2010/main" xmlns:m="http://schemas.openxmlformats.org/officeDocument/2006/math" xmlns="" val="1"/>
+              <ma14:wrappingTextBoxFlag xmlns="" xmlns:m="http://schemas.openxmlformats.org/officeDocument/2006/math" xmlns:a14="http://schemas.microsoft.com/office/drawing/2010/main" xmlns:ma14="http://schemas.microsoft.com/office/mac/drawingml/2011/main" val="1"/>
             </a:ext>
           </a:extLst>
         </p:spPr>
@@ -1630,7 +1701,7 @@
           </a:ln>
           <a:extLst>
             <a:ext uri="{C572A759-6A51-4108-AA02-DFA0A04FC94B}">
-              <ma14:wrappingTextBoxFlag xmlns:ma14="http://schemas.microsoft.com/office/mac/drawingml/2011/main" xmlns:a14="http://schemas.microsoft.com/office/drawing/2010/main" xmlns:m="http://schemas.openxmlformats.org/officeDocument/2006/math" xmlns="" val="1"/>
+              <ma14:wrappingTextBoxFlag xmlns="" xmlns:m="http://schemas.openxmlformats.org/officeDocument/2006/math" xmlns:a14="http://schemas.microsoft.com/office/drawing/2010/main" xmlns:ma14="http://schemas.microsoft.com/office/mac/drawingml/2011/main" val="1"/>
             </a:ext>
           </a:extLst>
         </p:spPr>
@@ -1810,7 +1881,7 @@
           </a:ln>
           <a:extLst>
             <a:ext uri="{C572A759-6A51-4108-AA02-DFA0A04FC94B}">
-              <ma14:wrappingTextBoxFlag xmlns:ma14="http://schemas.microsoft.com/office/mac/drawingml/2011/main" xmlns:a14="http://schemas.microsoft.com/office/drawing/2010/main" xmlns:m="http://schemas.openxmlformats.org/officeDocument/2006/math" xmlns="" val="1"/>
+              <ma14:wrappingTextBoxFlag xmlns="" xmlns:m="http://schemas.openxmlformats.org/officeDocument/2006/math" xmlns:a14="http://schemas.microsoft.com/office/drawing/2010/main" xmlns:ma14="http://schemas.microsoft.com/office/mac/drawingml/2011/main" val="1"/>
             </a:ext>
           </a:extLst>
         </p:spPr>
@@ -1854,7 +1925,7 @@
           </a:ln>
           <a:extLst>
             <a:ext uri="{C572A759-6A51-4108-AA02-DFA0A04FC94B}">
-              <ma14:wrappingTextBoxFlag xmlns:ma14="http://schemas.microsoft.com/office/mac/drawingml/2011/main" xmlns:a14="http://schemas.microsoft.com/office/drawing/2010/main" xmlns:m="http://schemas.openxmlformats.org/officeDocument/2006/math" xmlns="" val="1"/>
+              <ma14:wrappingTextBoxFlag xmlns="" xmlns:m="http://schemas.openxmlformats.org/officeDocument/2006/math" xmlns:a14="http://schemas.microsoft.com/office/drawing/2010/main" xmlns:ma14="http://schemas.microsoft.com/office/mac/drawingml/2011/main" val="1"/>
             </a:ext>
           </a:extLst>
         </p:spPr>
@@ -1898,7 +1969,7 @@
           </a:ln>
           <a:extLst>
             <a:ext uri="{C572A759-6A51-4108-AA02-DFA0A04FC94B}">
-              <ma14:wrappingTextBoxFlag xmlns:ma14="http://schemas.microsoft.com/office/mac/drawingml/2011/main" xmlns:a14="http://schemas.microsoft.com/office/drawing/2010/main" xmlns:m="http://schemas.openxmlformats.org/officeDocument/2006/math" xmlns="" val="1"/>
+              <ma14:wrappingTextBoxFlag xmlns="" xmlns:m="http://schemas.openxmlformats.org/officeDocument/2006/math" xmlns:a14="http://schemas.microsoft.com/office/drawing/2010/main" xmlns:ma14="http://schemas.microsoft.com/office/mac/drawingml/2011/main" val="1"/>
             </a:ext>
           </a:extLst>
         </p:spPr>
@@ -1941,7 +2012,7 @@
           </a:ln>
           <a:extLst>
             <a:ext uri="{C572A759-6A51-4108-AA02-DFA0A04FC94B}">
-              <ma14:wrappingTextBoxFlag xmlns:ma14="http://schemas.microsoft.com/office/mac/drawingml/2011/main" xmlns:a14="http://schemas.microsoft.com/office/drawing/2010/main" xmlns:m="http://schemas.openxmlformats.org/officeDocument/2006/math" xmlns="" val="1"/>
+              <ma14:wrappingTextBoxFlag xmlns="" xmlns:m="http://schemas.openxmlformats.org/officeDocument/2006/math" xmlns:a14="http://schemas.microsoft.com/office/drawing/2010/main" xmlns:ma14="http://schemas.microsoft.com/office/mac/drawingml/2011/main" val="1"/>
             </a:ext>
           </a:extLst>
         </p:spPr>
@@ -2023,7 +2094,7 @@
           </a:ln>
           <a:extLst>
             <a:ext uri="{C572A759-6A51-4108-AA02-DFA0A04FC94B}">
-              <ma14:wrappingTextBoxFlag xmlns:ma14="http://schemas.microsoft.com/office/mac/drawingml/2011/main" xmlns:a14="http://schemas.microsoft.com/office/drawing/2010/main" xmlns:m="http://schemas.openxmlformats.org/officeDocument/2006/math" xmlns="" val="1"/>
+              <ma14:wrappingTextBoxFlag xmlns="" xmlns:m="http://schemas.openxmlformats.org/officeDocument/2006/math" xmlns:a14="http://schemas.microsoft.com/office/drawing/2010/main" xmlns:ma14="http://schemas.microsoft.com/office/mac/drawingml/2011/main" val="1"/>
             </a:ext>
           </a:extLst>
         </p:spPr>
@@ -2121,7 +2192,7 @@
           </a:ln>
           <a:extLst>
             <a:ext uri="{C572A759-6A51-4108-AA02-DFA0A04FC94B}">
-              <ma14:wrappingTextBoxFlag xmlns:ma14="http://schemas.microsoft.com/office/mac/drawingml/2011/main" xmlns:a14="http://schemas.microsoft.com/office/drawing/2010/main" xmlns:m="http://schemas.openxmlformats.org/officeDocument/2006/math" xmlns="" val="1"/>
+              <ma14:wrappingTextBoxFlag xmlns="" xmlns:m="http://schemas.openxmlformats.org/officeDocument/2006/math" xmlns:a14="http://schemas.microsoft.com/office/drawing/2010/main" xmlns:ma14="http://schemas.microsoft.com/office/mac/drawingml/2011/main" val="1"/>
             </a:ext>
           </a:extLst>
         </p:spPr>
@@ -2164,7 +2235,7 @@
           </a:ln>
           <a:extLst>
             <a:ext uri="{C572A759-6A51-4108-AA02-DFA0A04FC94B}">
-              <ma14:wrappingTextBoxFlag xmlns:ma14="http://schemas.microsoft.com/office/mac/drawingml/2011/main" xmlns:a14="http://schemas.microsoft.com/office/drawing/2010/main" xmlns:m="http://schemas.openxmlformats.org/officeDocument/2006/math" xmlns="" val="1"/>
+              <ma14:wrappingTextBoxFlag xmlns="" xmlns:m="http://schemas.openxmlformats.org/officeDocument/2006/math" xmlns:a14="http://schemas.microsoft.com/office/drawing/2010/main" xmlns:ma14="http://schemas.microsoft.com/office/mac/drawingml/2011/main" val="1"/>
             </a:ext>
           </a:extLst>
         </p:spPr>
@@ -2240,7 +2311,7 @@
           </a:ln>
           <a:extLst>
             <a:ext uri="{C572A759-6A51-4108-AA02-DFA0A04FC94B}">
-              <ma14:wrappingTextBoxFlag xmlns:ma14="http://schemas.microsoft.com/office/mac/drawingml/2011/main" xmlns:a14="http://schemas.microsoft.com/office/drawing/2010/main" xmlns:m="http://schemas.openxmlformats.org/officeDocument/2006/math" xmlns="" val="1"/>
+              <ma14:wrappingTextBoxFlag xmlns="" xmlns:m="http://schemas.openxmlformats.org/officeDocument/2006/math" xmlns:a14="http://schemas.microsoft.com/office/drawing/2010/main" xmlns:ma14="http://schemas.microsoft.com/office/mac/drawingml/2011/main" val="1"/>
             </a:ext>
           </a:extLst>
         </p:spPr>
@@ -2313,7 +2384,7 @@
           </a:ln>
           <a:extLst>
             <a:ext uri="{C572A759-6A51-4108-AA02-DFA0A04FC94B}">
-              <ma14:wrappingTextBoxFlag xmlns:ma14="http://schemas.microsoft.com/office/mac/drawingml/2011/main" xmlns:a14="http://schemas.microsoft.com/office/drawing/2010/main" xmlns:m="http://schemas.openxmlformats.org/officeDocument/2006/math" xmlns="" val="1"/>
+              <ma14:wrappingTextBoxFlag xmlns="" xmlns:m="http://schemas.openxmlformats.org/officeDocument/2006/math" xmlns:a14="http://schemas.microsoft.com/office/drawing/2010/main" xmlns:ma14="http://schemas.microsoft.com/office/mac/drawingml/2011/main" val="1"/>
             </a:ext>
           </a:extLst>
         </p:spPr>
@@ -2356,7 +2427,7 @@
           </a:ln>
           <a:extLst>
             <a:ext uri="{C572A759-6A51-4108-AA02-DFA0A04FC94B}">
-              <ma14:wrappingTextBoxFlag xmlns:ma14="http://schemas.microsoft.com/office/mac/drawingml/2011/main" xmlns:a14="http://schemas.microsoft.com/office/drawing/2010/main" xmlns:m="http://schemas.openxmlformats.org/officeDocument/2006/math" xmlns="" val="1"/>
+              <ma14:wrappingTextBoxFlag xmlns="" xmlns:m="http://schemas.openxmlformats.org/officeDocument/2006/math" xmlns:a14="http://schemas.microsoft.com/office/drawing/2010/main" xmlns:ma14="http://schemas.microsoft.com/office/mac/drawingml/2011/main" val="1"/>
             </a:ext>
           </a:extLst>
         </p:spPr>
@@ -2399,7 +2470,7 @@
           </a:ln>
           <a:extLst>
             <a:ext uri="{C572A759-6A51-4108-AA02-DFA0A04FC94B}">
-              <ma14:wrappingTextBoxFlag xmlns:ma14="http://schemas.microsoft.com/office/mac/drawingml/2011/main" xmlns:a14="http://schemas.microsoft.com/office/drawing/2010/main" xmlns:m="http://schemas.openxmlformats.org/officeDocument/2006/math" xmlns="" val="1"/>
+              <ma14:wrappingTextBoxFlag xmlns="" xmlns:m="http://schemas.openxmlformats.org/officeDocument/2006/math" xmlns:a14="http://schemas.microsoft.com/office/drawing/2010/main" xmlns:ma14="http://schemas.microsoft.com/office/mac/drawingml/2011/main" val="1"/>
             </a:ext>
           </a:extLst>
         </p:spPr>
@@ -2443,7 +2514,7 @@
           </a:ln>
           <a:extLst>
             <a:ext uri="{C572A759-6A51-4108-AA02-DFA0A04FC94B}">
-              <ma14:wrappingTextBoxFlag xmlns:ma14="http://schemas.microsoft.com/office/mac/drawingml/2011/main" xmlns:a14="http://schemas.microsoft.com/office/drawing/2010/main" xmlns:m="http://schemas.openxmlformats.org/officeDocument/2006/math" xmlns="" val="1"/>
+              <ma14:wrappingTextBoxFlag xmlns="" xmlns:m="http://schemas.openxmlformats.org/officeDocument/2006/math" xmlns:a14="http://schemas.microsoft.com/office/drawing/2010/main" xmlns:ma14="http://schemas.microsoft.com/office/mac/drawingml/2011/main" val="1"/>
             </a:ext>
           </a:extLst>
         </p:spPr>
@@ -2487,7 +2558,7 @@
           </a:ln>
           <a:extLst>
             <a:ext uri="{C572A759-6A51-4108-AA02-DFA0A04FC94B}">
-              <ma14:wrappingTextBoxFlag xmlns:ma14="http://schemas.microsoft.com/office/mac/drawingml/2011/main" xmlns:a14="http://schemas.microsoft.com/office/drawing/2010/main" xmlns:m="http://schemas.openxmlformats.org/officeDocument/2006/math" xmlns="" val="1"/>
+              <ma14:wrappingTextBoxFlag xmlns="" xmlns:m="http://schemas.openxmlformats.org/officeDocument/2006/math" xmlns:a14="http://schemas.microsoft.com/office/drawing/2010/main" xmlns:ma14="http://schemas.microsoft.com/office/mac/drawingml/2011/main" val="1"/>
             </a:ext>
           </a:extLst>
         </p:spPr>
@@ -2530,7 +2601,7 @@
           </a:ln>
           <a:extLst>
             <a:ext uri="{C572A759-6A51-4108-AA02-DFA0A04FC94B}">
-              <ma14:wrappingTextBoxFlag xmlns:ma14="http://schemas.microsoft.com/office/mac/drawingml/2011/main" xmlns:a14="http://schemas.microsoft.com/office/drawing/2010/main" xmlns:m="http://schemas.openxmlformats.org/officeDocument/2006/math" xmlns="" val="1"/>
+              <ma14:wrappingTextBoxFlag xmlns="" xmlns:m="http://schemas.openxmlformats.org/officeDocument/2006/math" xmlns:a14="http://schemas.microsoft.com/office/drawing/2010/main" xmlns:ma14="http://schemas.microsoft.com/office/mac/drawingml/2011/main" val="1"/>
             </a:ext>
           </a:extLst>
         </p:spPr>
@@ -2574,7 +2645,7 @@
           </a:ln>
           <a:extLst>
             <a:ext uri="{C572A759-6A51-4108-AA02-DFA0A04FC94B}">
-              <ma14:wrappingTextBoxFlag xmlns:ma14="http://schemas.microsoft.com/office/mac/drawingml/2011/main" xmlns:a14="http://schemas.microsoft.com/office/drawing/2010/main" xmlns:m="http://schemas.openxmlformats.org/officeDocument/2006/math" xmlns="" val="1"/>
+              <ma14:wrappingTextBoxFlag xmlns="" xmlns:m="http://schemas.openxmlformats.org/officeDocument/2006/math" xmlns:a14="http://schemas.microsoft.com/office/drawing/2010/main" xmlns:ma14="http://schemas.microsoft.com/office/mac/drawingml/2011/main" val="1"/>
             </a:ext>
           </a:extLst>
         </p:spPr>
@@ -2617,7 +2688,7 @@
           </a:ln>
           <a:extLst>
             <a:ext uri="{C572A759-6A51-4108-AA02-DFA0A04FC94B}">
-              <ma14:wrappingTextBoxFlag xmlns:ma14="http://schemas.microsoft.com/office/mac/drawingml/2011/main" xmlns:a14="http://schemas.microsoft.com/office/drawing/2010/main" xmlns:m="http://schemas.openxmlformats.org/officeDocument/2006/math" xmlns="" val="1"/>
+              <ma14:wrappingTextBoxFlag xmlns="" xmlns:m="http://schemas.openxmlformats.org/officeDocument/2006/math" xmlns:a14="http://schemas.microsoft.com/office/drawing/2010/main" xmlns:ma14="http://schemas.microsoft.com/office/mac/drawingml/2011/main" val="1"/>
             </a:ext>
           </a:extLst>
         </p:spPr>
@@ -2699,7 +2770,7 @@
           </a:ln>
           <a:extLst>
             <a:ext uri="{C572A759-6A51-4108-AA02-DFA0A04FC94B}">
-              <ma14:wrappingTextBoxFlag xmlns:ma14="http://schemas.microsoft.com/office/mac/drawingml/2011/main" xmlns:a14="http://schemas.microsoft.com/office/drawing/2010/main" xmlns:m="http://schemas.openxmlformats.org/officeDocument/2006/math" xmlns="" val="1"/>
+              <ma14:wrappingTextBoxFlag xmlns="" xmlns:m="http://schemas.openxmlformats.org/officeDocument/2006/math" xmlns:a14="http://schemas.microsoft.com/office/drawing/2010/main" xmlns:ma14="http://schemas.microsoft.com/office/mac/drawingml/2011/main" val="1"/>
             </a:ext>
           </a:extLst>
         </p:spPr>
@@ -2772,7 +2843,7 @@
           </a:ln>
           <a:extLst>
             <a:ext uri="{C572A759-6A51-4108-AA02-DFA0A04FC94B}">
-              <ma14:wrappingTextBoxFlag xmlns:ma14="http://schemas.microsoft.com/office/mac/drawingml/2011/main" xmlns:a14="http://schemas.microsoft.com/office/drawing/2010/main" xmlns:m="http://schemas.openxmlformats.org/officeDocument/2006/math" xmlns="" val="1"/>
+              <ma14:wrappingTextBoxFlag xmlns="" xmlns:m="http://schemas.openxmlformats.org/officeDocument/2006/math" xmlns:a14="http://schemas.microsoft.com/office/drawing/2010/main" xmlns:ma14="http://schemas.microsoft.com/office/mac/drawingml/2011/main" val="1"/>
             </a:ext>
           </a:extLst>
         </p:spPr>
@@ -2815,7 +2886,7 @@
           </a:ln>
           <a:extLst>
             <a:ext uri="{C572A759-6A51-4108-AA02-DFA0A04FC94B}">
-              <ma14:wrappingTextBoxFlag xmlns:ma14="http://schemas.microsoft.com/office/mac/drawingml/2011/main" xmlns:a14="http://schemas.microsoft.com/office/drawing/2010/main" xmlns:m="http://schemas.openxmlformats.org/officeDocument/2006/math" xmlns="" val="1"/>
+              <ma14:wrappingTextBoxFlag xmlns="" xmlns:m="http://schemas.openxmlformats.org/officeDocument/2006/math" xmlns:a14="http://schemas.microsoft.com/office/drawing/2010/main" xmlns:ma14="http://schemas.microsoft.com/office/mac/drawingml/2011/main" val="1"/>
             </a:ext>
           </a:extLst>
         </p:spPr>
@@ -2913,7 +2984,7 @@
           </a:ln>
           <a:extLst>
             <a:ext uri="{C572A759-6A51-4108-AA02-DFA0A04FC94B}">
-              <ma14:wrappingTextBoxFlag xmlns:ma14="http://schemas.microsoft.com/office/mac/drawingml/2011/main" xmlns:a14="http://schemas.microsoft.com/office/drawing/2010/main" xmlns:m="http://schemas.openxmlformats.org/officeDocument/2006/math" xmlns="" val="1"/>
+              <ma14:wrappingTextBoxFlag xmlns="" xmlns:m="http://schemas.openxmlformats.org/officeDocument/2006/math" xmlns:a14="http://schemas.microsoft.com/office/drawing/2010/main" xmlns:ma14="http://schemas.microsoft.com/office/mac/drawingml/2011/main" val="1"/>
             </a:ext>
           </a:extLst>
         </p:spPr>
@@ -2956,7 +3027,7 @@
           </a:ln>
           <a:extLst>
             <a:ext uri="{C572A759-6A51-4108-AA02-DFA0A04FC94B}">
-              <ma14:wrappingTextBoxFlag xmlns:ma14="http://schemas.microsoft.com/office/mac/drawingml/2011/main" xmlns:a14="http://schemas.microsoft.com/office/drawing/2010/main" xmlns:m="http://schemas.openxmlformats.org/officeDocument/2006/math" xmlns="" val="1"/>
+              <ma14:wrappingTextBoxFlag xmlns="" xmlns:m="http://schemas.openxmlformats.org/officeDocument/2006/math" xmlns:a14="http://schemas.microsoft.com/office/drawing/2010/main" xmlns:ma14="http://schemas.microsoft.com/office/mac/drawingml/2011/main" val="1"/>
             </a:ext>
           </a:extLst>
         </p:spPr>
@@ -3032,7 +3103,7 @@
           </a:ln>
           <a:extLst>
             <a:ext uri="{C572A759-6A51-4108-AA02-DFA0A04FC94B}">
-              <ma14:wrappingTextBoxFlag xmlns:ma14="http://schemas.microsoft.com/office/mac/drawingml/2011/main" xmlns:a14="http://schemas.microsoft.com/office/drawing/2010/main" xmlns:m="http://schemas.openxmlformats.org/officeDocument/2006/math" xmlns="" val="1"/>
+              <ma14:wrappingTextBoxFlag xmlns="" xmlns:m="http://schemas.openxmlformats.org/officeDocument/2006/math" xmlns:a14="http://schemas.microsoft.com/office/drawing/2010/main" xmlns:ma14="http://schemas.microsoft.com/office/mac/drawingml/2011/main" val="1"/>
             </a:ext>
           </a:extLst>
         </p:spPr>
@@ -3104,7 +3175,7 @@
           </a:ln>
           <a:extLst>
             <a:ext uri="{C572A759-6A51-4108-AA02-DFA0A04FC94B}">
-              <ma14:wrappingTextBoxFlag xmlns:ma14="http://schemas.microsoft.com/office/mac/drawingml/2011/main" xmlns:a14="http://schemas.microsoft.com/office/drawing/2010/main" xmlns:m="http://schemas.openxmlformats.org/officeDocument/2006/math" xmlns="" val="1"/>
+              <ma14:wrappingTextBoxFlag xmlns="" xmlns:m="http://schemas.openxmlformats.org/officeDocument/2006/math" xmlns:a14="http://schemas.microsoft.com/office/drawing/2010/main" xmlns:ma14="http://schemas.microsoft.com/office/mac/drawingml/2011/main" val="1"/>
             </a:ext>
           </a:extLst>
         </p:spPr>
@@ -3147,7 +3218,7 @@
           </a:ln>
           <a:extLst>
             <a:ext uri="{C572A759-6A51-4108-AA02-DFA0A04FC94B}">
-              <ma14:wrappingTextBoxFlag xmlns:ma14="http://schemas.microsoft.com/office/mac/drawingml/2011/main" xmlns:a14="http://schemas.microsoft.com/office/drawing/2010/main" xmlns:m="http://schemas.openxmlformats.org/officeDocument/2006/math" xmlns="" val="1"/>
+              <ma14:wrappingTextBoxFlag xmlns="" xmlns:m="http://schemas.openxmlformats.org/officeDocument/2006/math" xmlns:a14="http://schemas.microsoft.com/office/drawing/2010/main" xmlns:ma14="http://schemas.microsoft.com/office/mac/drawingml/2011/main" val="1"/>
             </a:ext>
           </a:extLst>
         </p:spPr>
@@ -3191,7 +3262,7 @@
           </a:ln>
           <a:extLst>
             <a:ext uri="{C572A759-6A51-4108-AA02-DFA0A04FC94B}">
-              <ma14:wrappingTextBoxFlag xmlns:ma14="http://schemas.microsoft.com/office/mac/drawingml/2011/main" xmlns:a14="http://schemas.microsoft.com/office/drawing/2010/main" xmlns:m="http://schemas.openxmlformats.org/officeDocument/2006/math" xmlns="" val="1"/>
+              <ma14:wrappingTextBoxFlag xmlns="" xmlns:m="http://schemas.openxmlformats.org/officeDocument/2006/math" xmlns:a14="http://schemas.microsoft.com/office/drawing/2010/main" xmlns:ma14="http://schemas.microsoft.com/office/mac/drawingml/2011/main" val="1"/>
             </a:ext>
           </a:extLst>
         </p:spPr>
@@ -3268,7 +3339,7 @@
           </a:ln>
           <a:extLst>
             <a:ext uri="{C572A759-6A51-4108-AA02-DFA0A04FC94B}">
-              <ma14:wrappingTextBoxFlag xmlns:ma14="http://schemas.microsoft.com/office/mac/drawingml/2011/main" xmlns:a14="http://schemas.microsoft.com/office/drawing/2010/main" xmlns:m="http://schemas.openxmlformats.org/officeDocument/2006/math" xmlns="" val="1"/>
+              <ma14:wrappingTextBoxFlag xmlns="" xmlns:m="http://schemas.openxmlformats.org/officeDocument/2006/math" xmlns:a14="http://schemas.microsoft.com/office/drawing/2010/main" xmlns:ma14="http://schemas.microsoft.com/office/mac/drawingml/2011/main" val="1"/>
             </a:ext>
           </a:extLst>
         </p:spPr>
@@ -3311,7 +3382,7 @@
           </a:ln>
           <a:extLst>
             <a:ext uri="{C572A759-6A51-4108-AA02-DFA0A04FC94B}">
-              <ma14:wrappingTextBoxFlag xmlns:ma14="http://schemas.microsoft.com/office/mac/drawingml/2011/main" xmlns:a14="http://schemas.microsoft.com/office/drawing/2010/main" xmlns:m="http://schemas.openxmlformats.org/officeDocument/2006/math" xmlns="" val="1"/>
+              <ma14:wrappingTextBoxFlag xmlns="" xmlns:m="http://schemas.openxmlformats.org/officeDocument/2006/math" xmlns:a14="http://schemas.microsoft.com/office/drawing/2010/main" xmlns:ma14="http://schemas.microsoft.com/office/mac/drawingml/2011/main" val="1"/>
             </a:ext>
           </a:extLst>
         </p:spPr>
@@ -3354,7 +3425,7 @@
           </a:ln>
           <a:extLst>
             <a:ext uri="{C572A759-6A51-4108-AA02-DFA0A04FC94B}">
-              <ma14:wrappingTextBoxFlag xmlns:ma14="http://schemas.microsoft.com/office/mac/drawingml/2011/main" xmlns:a14="http://schemas.microsoft.com/office/drawing/2010/main" xmlns:m="http://schemas.openxmlformats.org/officeDocument/2006/math" xmlns="" val="1"/>
+              <ma14:wrappingTextBoxFlag xmlns="" xmlns:m="http://schemas.openxmlformats.org/officeDocument/2006/math" xmlns:a14="http://schemas.microsoft.com/office/drawing/2010/main" xmlns:ma14="http://schemas.microsoft.com/office/mac/drawingml/2011/main" val="1"/>
             </a:ext>
           </a:extLst>
         </p:spPr>
@@ -3413,7 +3484,7 @@
           </a:ln>
           <a:extLst>
             <a:ext uri="{C572A759-6A51-4108-AA02-DFA0A04FC94B}">
-              <ma14:wrappingTextBoxFlag xmlns:ma14="http://schemas.microsoft.com/office/mac/drawingml/2011/main" xmlns:a14="http://schemas.microsoft.com/office/drawing/2010/main" xmlns:m="http://schemas.openxmlformats.org/officeDocument/2006/math" xmlns="" val="1"/>
+              <ma14:wrappingTextBoxFlag xmlns="" xmlns:m="http://schemas.openxmlformats.org/officeDocument/2006/math" xmlns:a14="http://schemas.microsoft.com/office/drawing/2010/main" xmlns:ma14="http://schemas.microsoft.com/office/mac/drawingml/2011/main" val="1"/>
             </a:ext>
           </a:extLst>
         </p:spPr>
@@ -3456,7 +3527,7 @@
           </a:ln>
           <a:extLst>
             <a:ext uri="{C572A759-6A51-4108-AA02-DFA0A04FC94B}">
-              <ma14:wrappingTextBoxFlag xmlns:ma14="http://schemas.microsoft.com/office/mac/drawingml/2011/main" xmlns:a14="http://schemas.microsoft.com/office/drawing/2010/main" xmlns:m="http://schemas.openxmlformats.org/officeDocument/2006/math" xmlns="" val="1"/>
+              <ma14:wrappingTextBoxFlag xmlns="" xmlns:m="http://schemas.openxmlformats.org/officeDocument/2006/math" xmlns:a14="http://schemas.microsoft.com/office/drawing/2010/main" xmlns:ma14="http://schemas.microsoft.com/office/mac/drawingml/2011/main" val="1"/>
             </a:ext>
           </a:extLst>
         </p:spPr>
@@ -3515,7 +3586,7 @@
           </a:ln>
           <a:extLst>
             <a:ext uri="{C572A759-6A51-4108-AA02-DFA0A04FC94B}">
-              <ma14:wrappingTextBoxFlag xmlns:ma14="http://schemas.microsoft.com/office/mac/drawingml/2011/main" xmlns:a14="http://schemas.microsoft.com/office/drawing/2010/main" xmlns:m="http://schemas.openxmlformats.org/officeDocument/2006/math" xmlns="" val="1"/>
+              <ma14:wrappingTextBoxFlag xmlns="" xmlns:m="http://schemas.openxmlformats.org/officeDocument/2006/math" xmlns:a14="http://schemas.microsoft.com/office/drawing/2010/main" xmlns:ma14="http://schemas.microsoft.com/office/mac/drawingml/2011/main" val="1"/>
             </a:ext>
           </a:extLst>
         </p:spPr>
@@ -3558,7 +3629,7 @@
           </a:ln>
           <a:extLst>
             <a:ext uri="{C572A759-6A51-4108-AA02-DFA0A04FC94B}">
-              <ma14:wrappingTextBoxFlag xmlns:ma14="http://schemas.microsoft.com/office/mac/drawingml/2011/main" xmlns:a14="http://schemas.microsoft.com/office/drawing/2010/main" xmlns:m="http://schemas.openxmlformats.org/officeDocument/2006/math" xmlns="" val="1"/>
+              <ma14:wrappingTextBoxFlag xmlns="" xmlns:m="http://schemas.openxmlformats.org/officeDocument/2006/math" xmlns:a14="http://schemas.microsoft.com/office/drawing/2010/main" xmlns:ma14="http://schemas.microsoft.com/office/mac/drawingml/2011/main" val="1"/>
             </a:ext>
           </a:extLst>
         </p:spPr>
@@ -3646,7 +3717,7 @@
           </a:ln>
           <a:extLst>
             <a:ext uri="{C572A759-6A51-4108-AA02-DFA0A04FC94B}">
-              <ma14:wrappingTextBoxFlag xmlns:ma14="http://schemas.microsoft.com/office/mac/drawingml/2011/main" xmlns:a14="http://schemas.microsoft.com/office/drawing/2010/main" xmlns:m="http://schemas.openxmlformats.org/officeDocument/2006/math" xmlns="" val="1"/>
+              <ma14:wrappingTextBoxFlag xmlns="" xmlns:m="http://schemas.openxmlformats.org/officeDocument/2006/math" xmlns:a14="http://schemas.microsoft.com/office/drawing/2010/main" xmlns:ma14="http://schemas.microsoft.com/office/mac/drawingml/2011/main" val="1"/>
             </a:ext>
           </a:extLst>
         </p:spPr>
@@ -3689,7 +3760,7 @@
           </a:ln>
           <a:extLst>
             <a:ext uri="{C572A759-6A51-4108-AA02-DFA0A04FC94B}">
-              <ma14:wrappingTextBoxFlag xmlns:ma14="http://schemas.microsoft.com/office/mac/drawingml/2011/main" xmlns:a14="http://schemas.microsoft.com/office/drawing/2010/main" xmlns:m="http://schemas.openxmlformats.org/officeDocument/2006/math" xmlns="" val="1"/>
+              <ma14:wrappingTextBoxFlag xmlns="" xmlns:m="http://schemas.openxmlformats.org/officeDocument/2006/math" xmlns:a14="http://schemas.microsoft.com/office/drawing/2010/main" xmlns:ma14="http://schemas.microsoft.com/office/mac/drawingml/2011/main" val="1"/>
             </a:ext>
           </a:extLst>
         </p:spPr>
@@ -5124,7 +5195,7 @@
           </a:ln>
           <a:extLst>
             <a:ext uri="{C572A759-6A51-4108-AA02-DFA0A04FC94B}">
-              <ma14:wrappingTextBoxFlag xmlns:ma14="http://schemas.microsoft.com/office/mac/drawingml/2011/main" xmlns:a14="http://schemas.microsoft.com/office/drawing/2010/main" xmlns:m="http://schemas.openxmlformats.org/officeDocument/2006/math" xmlns="" val="1"/>
+              <ma14:wrappingTextBoxFlag xmlns="" xmlns:m="http://schemas.openxmlformats.org/officeDocument/2006/math" xmlns:a14="http://schemas.microsoft.com/office/drawing/2010/main" xmlns:ma14="http://schemas.microsoft.com/office/mac/drawingml/2011/main" val="1"/>
             </a:ext>
           </a:extLst>
         </p:spPr>
@@ -5167,7 +5238,7 @@
           </a:ln>
           <a:extLst>
             <a:ext uri="{C572A759-6A51-4108-AA02-DFA0A04FC94B}">
-              <ma14:wrappingTextBoxFlag xmlns:ma14="http://schemas.microsoft.com/office/mac/drawingml/2011/main" xmlns:a14="http://schemas.microsoft.com/office/drawing/2010/main" xmlns:m="http://schemas.openxmlformats.org/officeDocument/2006/math" xmlns="" val="1"/>
+              <ma14:wrappingTextBoxFlag xmlns="" xmlns:m="http://schemas.openxmlformats.org/officeDocument/2006/math" xmlns:a14="http://schemas.microsoft.com/office/drawing/2010/main" xmlns:ma14="http://schemas.microsoft.com/office/mac/drawingml/2011/main" val="1"/>
             </a:ext>
           </a:extLst>
         </p:spPr>
@@ -5243,7 +5314,7 @@
           </a:ln>
           <a:extLst>
             <a:ext uri="{C572A759-6A51-4108-AA02-DFA0A04FC94B}">
-              <ma14:wrappingTextBoxFlag xmlns:ma14="http://schemas.microsoft.com/office/mac/drawingml/2011/main" xmlns:a14="http://schemas.microsoft.com/office/drawing/2010/main" xmlns:m="http://schemas.openxmlformats.org/officeDocument/2006/math" xmlns="" val="1"/>
+              <ma14:wrappingTextBoxFlag xmlns="" xmlns:m="http://schemas.openxmlformats.org/officeDocument/2006/math" xmlns:a14="http://schemas.microsoft.com/office/drawing/2010/main" xmlns:ma14="http://schemas.microsoft.com/office/mac/drawingml/2011/main" val="1"/>
             </a:ext>
           </a:extLst>
         </p:spPr>
@@ -5348,7 +5419,7 @@
           </a:ln>
           <a:extLst>
             <a:ext uri="{C572A759-6A51-4108-AA02-DFA0A04FC94B}">
-              <ma14:wrappingTextBoxFlag xmlns:ma14="http://schemas.microsoft.com/office/mac/drawingml/2011/main" xmlns:a14="http://schemas.microsoft.com/office/drawing/2010/main" xmlns:m="http://schemas.openxmlformats.org/officeDocument/2006/math" xmlns="" val="1"/>
+              <ma14:wrappingTextBoxFlag xmlns="" xmlns:m="http://schemas.openxmlformats.org/officeDocument/2006/math" xmlns:a14="http://schemas.microsoft.com/office/drawing/2010/main" xmlns:ma14="http://schemas.microsoft.com/office/mac/drawingml/2011/main" val="1"/>
             </a:ext>
           </a:extLst>
         </p:spPr>
@@ -5391,7 +5462,7 @@
           </a:ln>
           <a:extLst>
             <a:ext uri="{C572A759-6A51-4108-AA02-DFA0A04FC94B}">
-              <ma14:wrappingTextBoxFlag xmlns:ma14="http://schemas.microsoft.com/office/mac/drawingml/2011/main" xmlns:a14="http://schemas.microsoft.com/office/drawing/2010/main" xmlns:m="http://schemas.openxmlformats.org/officeDocument/2006/math" xmlns="" val="1"/>
+              <ma14:wrappingTextBoxFlag xmlns="" xmlns:m="http://schemas.openxmlformats.org/officeDocument/2006/math" xmlns:a14="http://schemas.microsoft.com/office/drawing/2010/main" xmlns:ma14="http://schemas.microsoft.com/office/mac/drawingml/2011/main" val="1"/>
             </a:ext>
           </a:extLst>
         </p:spPr>
@@ -5542,7 +5613,7 @@
           </a:ln>
           <a:extLst>
             <a:ext uri="{C572A759-6A51-4108-AA02-DFA0A04FC94B}">
-              <ma14:wrappingTextBoxFlag xmlns:ma14="http://schemas.microsoft.com/office/mac/drawingml/2011/main" xmlns:a14="http://schemas.microsoft.com/office/drawing/2010/main" xmlns:m="http://schemas.openxmlformats.org/officeDocument/2006/math" xmlns="" val="1"/>
+              <ma14:wrappingTextBoxFlag xmlns="" xmlns:m="http://schemas.openxmlformats.org/officeDocument/2006/math" xmlns:a14="http://schemas.microsoft.com/office/drawing/2010/main" xmlns:ma14="http://schemas.microsoft.com/office/mac/drawingml/2011/main" val="1"/>
             </a:ext>
           </a:extLst>
         </p:spPr>
@@ -5585,7 +5656,7 @@
           </a:ln>
           <a:extLst>
             <a:ext uri="{C572A759-6A51-4108-AA02-DFA0A04FC94B}">
-              <ma14:wrappingTextBoxFlag xmlns:ma14="http://schemas.microsoft.com/office/mac/drawingml/2011/main" xmlns:a14="http://schemas.microsoft.com/office/drawing/2010/main" xmlns:m="http://schemas.openxmlformats.org/officeDocument/2006/math" xmlns="" val="1"/>
+              <ma14:wrappingTextBoxFlag xmlns="" xmlns:m="http://schemas.openxmlformats.org/officeDocument/2006/math" xmlns:a14="http://schemas.microsoft.com/office/drawing/2010/main" xmlns:ma14="http://schemas.microsoft.com/office/mac/drawingml/2011/main" val="1"/>
             </a:ext>
           </a:extLst>
         </p:spPr>
@@ -5734,7 +5805,7 @@
           </a:ln>
           <a:extLst>
             <a:ext uri="{C572A759-6A51-4108-AA02-DFA0A04FC94B}">
-              <ma14:wrappingTextBoxFlag xmlns:ma14="http://schemas.microsoft.com/office/mac/drawingml/2011/main" xmlns:a14="http://schemas.microsoft.com/office/drawing/2010/main" xmlns:m="http://schemas.openxmlformats.org/officeDocument/2006/math" xmlns="" val="1"/>
+              <ma14:wrappingTextBoxFlag xmlns="" xmlns:m="http://schemas.openxmlformats.org/officeDocument/2006/math" xmlns:a14="http://schemas.microsoft.com/office/drawing/2010/main" xmlns:ma14="http://schemas.microsoft.com/office/mac/drawingml/2011/main" val="1"/>
             </a:ext>
           </a:extLst>
         </p:spPr>
@@ -5777,7 +5848,7 @@
           </a:ln>
           <a:extLst>
             <a:ext uri="{C572A759-6A51-4108-AA02-DFA0A04FC94B}">
-              <ma14:wrappingTextBoxFlag xmlns:ma14="http://schemas.microsoft.com/office/mac/drawingml/2011/main" xmlns:a14="http://schemas.microsoft.com/office/drawing/2010/main" xmlns:m="http://schemas.openxmlformats.org/officeDocument/2006/math" xmlns="" val="1"/>
+              <ma14:wrappingTextBoxFlag xmlns="" xmlns:m="http://schemas.openxmlformats.org/officeDocument/2006/math" xmlns:a14="http://schemas.microsoft.com/office/drawing/2010/main" xmlns:ma14="http://schemas.microsoft.com/office/mac/drawingml/2011/main" val="1"/>
             </a:ext>
           </a:extLst>
         </p:spPr>
@@ -5861,7 +5932,7 @@
           </a:ln>
           <a:extLst>
             <a:ext uri="{C572A759-6A51-4108-AA02-DFA0A04FC94B}">
-              <ma14:wrappingTextBoxFlag xmlns:ma14="http://schemas.microsoft.com/office/mac/drawingml/2011/main" xmlns:a14="http://schemas.microsoft.com/office/drawing/2010/main" xmlns:m="http://schemas.openxmlformats.org/officeDocument/2006/math" xmlns="" val="1"/>
+              <ma14:wrappingTextBoxFlag xmlns="" xmlns:m="http://schemas.openxmlformats.org/officeDocument/2006/math" xmlns:a14="http://schemas.microsoft.com/office/drawing/2010/main" xmlns:ma14="http://schemas.microsoft.com/office/mac/drawingml/2011/main" val="1"/>
             </a:ext>
           </a:extLst>
         </p:spPr>
@@ -5904,7 +5975,7 @@
           </a:ln>
           <a:extLst>
             <a:ext uri="{C572A759-6A51-4108-AA02-DFA0A04FC94B}">
-              <ma14:wrappingTextBoxFlag xmlns:ma14="http://schemas.microsoft.com/office/mac/drawingml/2011/main" xmlns:a14="http://schemas.microsoft.com/office/drawing/2010/main" xmlns:m="http://schemas.openxmlformats.org/officeDocument/2006/math" xmlns="" val="1"/>
+              <ma14:wrappingTextBoxFlag xmlns="" xmlns:m="http://schemas.openxmlformats.org/officeDocument/2006/math" xmlns:a14="http://schemas.microsoft.com/office/drawing/2010/main" xmlns:ma14="http://schemas.microsoft.com/office/mac/drawingml/2011/main" val="1"/>
             </a:ext>
           </a:extLst>
         </p:spPr>
@@ -6002,7 +6073,7 @@
           </a:ln>
           <a:extLst>
             <a:ext uri="{C572A759-6A51-4108-AA02-DFA0A04FC94B}">
-              <ma14:wrappingTextBoxFlag xmlns:ma14="http://schemas.microsoft.com/office/mac/drawingml/2011/main" xmlns:a14="http://schemas.microsoft.com/office/drawing/2010/main" xmlns:m="http://schemas.openxmlformats.org/officeDocument/2006/math" xmlns="" val="1"/>
+              <ma14:wrappingTextBoxFlag xmlns="" xmlns:m="http://schemas.openxmlformats.org/officeDocument/2006/math" xmlns:a14="http://schemas.microsoft.com/office/drawing/2010/main" xmlns:ma14="http://schemas.microsoft.com/office/mac/drawingml/2011/main" val="1"/>
             </a:ext>
           </a:extLst>
         </p:spPr>
@@ -6045,7 +6116,7 @@
           </a:ln>
           <a:extLst>
             <a:ext uri="{C572A759-6A51-4108-AA02-DFA0A04FC94B}">
-              <ma14:wrappingTextBoxFlag xmlns:ma14="http://schemas.microsoft.com/office/mac/drawingml/2011/main" xmlns:a14="http://schemas.microsoft.com/office/drawing/2010/main" xmlns:m="http://schemas.openxmlformats.org/officeDocument/2006/math" xmlns="" val="1"/>
+              <ma14:wrappingTextBoxFlag xmlns="" xmlns:m="http://schemas.openxmlformats.org/officeDocument/2006/math" xmlns:a14="http://schemas.microsoft.com/office/drawing/2010/main" xmlns:ma14="http://schemas.microsoft.com/office/mac/drawingml/2011/main" val="1"/>
             </a:ext>
           </a:extLst>
         </p:spPr>
@@ -6121,7 +6192,7 @@
           </a:ln>
           <a:extLst>
             <a:ext uri="{C572A759-6A51-4108-AA02-DFA0A04FC94B}">
-              <ma14:wrappingTextBoxFlag xmlns:ma14="http://schemas.microsoft.com/office/mac/drawingml/2011/main" xmlns:a14="http://schemas.microsoft.com/office/drawing/2010/main" xmlns:m="http://schemas.openxmlformats.org/officeDocument/2006/math" xmlns="" val="1"/>
+              <ma14:wrappingTextBoxFlag xmlns="" xmlns:m="http://schemas.openxmlformats.org/officeDocument/2006/math" xmlns:a14="http://schemas.microsoft.com/office/drawing/2010/main" xmlns:ma14="http://schemas.microsoft.com/office/mac/drawingml/2011/main" val="1"/>
             </a:ext>
           </a:extLst>
         </p:spPr>
@@ -6193,7 +6264,7 @@
           </a:ln>
           <a:extLst>
             <a:ext uri="{C572A759-6A51-4108-AA02-DFA0A04FC94B}">
-              <ma14:wrappingTextBoxFlag xmlns:ma14="http://schemas.microsoft.com/office/mac/drawingml/2011/main" xmlns:a14="http://schemas.microsoft.com/office/drawing/2010/main" xmlns:m="http://schemas.openxmlformats.org/officeDocument/2006/math" xmlns="" val="1"/>
+              <ma14:wrappingTextBoxFlag xmlns="" xmlns:m="http://schemas.openxmlformats.org/officeDocument/2006/math" xmlns:a14="http://schemas.microsoft.com/office/drawing/2010/main" xmlns:ma14="http://schemas.microsoft.com/office/mac/drawingml/2011/main" val="1"/>
             </a:ext>
           </a:extLst>
         </p:spPr>
@@ -6271,7 +6342,7 @@
           </a:ln>
           <a:extLst>
             <a:ext uri="{C572A759-6A51-4108-AA02-DFA0A04FC94B}">
-              <ma14:wrappingTextBoxFlag xmlns:ma14="http://schemas.microsoft.com/office/mac/drawingml/2011/main" xmlns:a14="http://schemas.microsoft.com/office/drawing/2010/main" xmlns:m="http://schemas.openxmlformats.org/officeDocument/2006/math" xmlns="" val="1"/>
+              <ma14:wrappingTextBoxFlag xmlns="" xmlns:m="http://schemas.openxmlformats.org/officeDocument/2006/math" xmlns:a14="http://schemas.microsoft.com/office/drawing/2010/main" xmlns:ma14="http://schemas.microsoft.com/office/mac/drawingml/2011/main" val="1"/>
             </a:ext>
           </a:extLst>
         </p:spPr>
@@ -6314,7 +6385,7 @@
           </a:ln>
           <a:extLst>
             <a:ext uri="{C572A759-6A51-4108-AA02-DFA0A04FC94B}">
-              <ma14:wrappingTextBoxFlag xmlns:ma14="http://schemas.microsoft.com/office/mac/drawingml/2011/main" xmlns:a14="http://schemas.microsoft.com/office/drawing/2010/main" xmlns:m="http://schemas.openxmlformats.org/officeDocument/2006/math" xmlns="" val="1"/>
+              <ma14:wrappingTextBoxFlag xmlns="" xmlns:m="http://schemas.openxmlformats.org/officeDocument/2006/math" xmlns:a14="http://schemas.microsoft.com/office/drawing/2010/main" xmlns:ma14="http://schemas.microsoft.com/office/mac/drawingml/2011/main" val="1"/>
             </a:ext>
           </a:extLst>
         </p:spPr>
@@ -6365,7 +6436,7 @@
           </a:ln>
           <a:extLst>
             <a:ext uri="{C572A759-6A51-4108-AA02-DFA0A04FC94B}">
-              <ma14:wrappingTextBoxFlag xmlns:ma14="http://schemas.microsoft.com/office/mac/drawingml/2011/main" xmlns:a14="http://schemas.microsoft.com/office/drawing/2010/main" xmlns:m="http://schemas.openxmlformats.org/officeDocument/2006/math" xmlns="" val="1"/>
+              <ma14:wrappingTextBoxFlag xmlns="" xmlns:m="http://schemas.openxmlformats.org/officeDocument/2006/math" xmlns:a14="http://schemas.microsoft.com/office/drawing/2010/main" xmlns:ma14="http://schemas.microsoft.com/office/mac/drawingml/2011/main" val="1"/>
             </a:ext>
           </a:extLst>
         </p:spPr>
@@ -6416,7 +6487,7 @@
           </a:ln>
           <a:extLst>
             <a:ext uri="{C572A759-6A51-4108-AA02-DFA0A04FC94B}">
-              <ma14:wrappingTextBoxFlag xmlns:ma14="http://schemas.microsoft.com/office/mac/drawingml/2011/main" xmlns:a14="http://schemas.microsoft.com/office/drawing/2010/main" xmlns:m="http://schemas.openxmlformats.org/officeDocument/2006/math" xmlns="" val="1"/>
+              <ma14:wrappingTextBoxFlag xmlns="" xmlns:m="http://schemas.openxmlformats.org/officeDocument/2006/math" xmlns:a14="http://schemas.microsoft.com/office/drawing/2010/main" xmlns:ma14="http://schemas.microsoft.com/office/mac/drawingml/2011/main" val="1"/>
             </a:ext>
           </a:extLst>
         </p:spPr>
@@ -6467,7 +6538,7 @@
           </a:ln>
           <a:extLst>
             <a:ext uri="{C572A759-6A51-4108-AA02-DFA0A04FC94B}">
-              <ma14:wrappingTextBoxFlag xmlns:ma14="http://schemas.microsoft.com/office/mac/drawingml/2011/main" xmlns:a14="http://schemas.microsoft.com/office/drawing/2010/main" xmlns:m="http://schemas.openxmlformats.org/officeDocument/2006/math" xmlns="" val="1"/>
+              <ma14:wrappingTextBoxFlag xmlns="" xmlns:m="http://schemas.openxmlformats.org/officeDocument/2006/math" xmlns:a14="http://schemas.microsoft.com/office/drawing/2010/main" xmlns:ma14="http://schemas.microsoft.com/office/mac/drawingml/2011/main" val="1"/>
             </a:ext>
           </a:extLst>
         </p:spPr>
@@ -6518,7 +6589,7 @@
           </a:ln>
           <a:extLst>
             <a:ext uri="{C572A759-6A51-4108-AA02-DFA0A04FC94B}">
-              <ma14:wrappingTextBoxFlag xmlns:ma14="http://schemas.microsoft.com/office/mac/drawingml/2011/main" xmlns:a14="http://schemas.microsoft.com/office/drawing/2010/main" xmlns:m="http://schemas.openxmlformats.org/officeDocument/2006/math" xmlns="" val="1"/>
+              <ma14:wrappingTextBoxFlag xmlns="" xmlns:m="http://schemas.openxmlformats.org/officeDocument/2006/math" xmlns:a14="http://schemas.microsoft.com/office/drawing/2010/main" xmlns:ma14="http://schemas.microsoft.com/office/mac/drawingml/2011/main" val="1"/>
             </a:ext>
           </a:extLst>
         </p:spPr>
@@ -6569,7 +6640,7 @@
           </a:ln>
           <a:extLst>
             <a:ext uri="{C572A759-6A51-4108-AA02-DFA0A04FC94B}">
-              <ma14:wrappingTextBoxFlag xmlns:ma14="http://schemas.microsoft.com/office/mac/drawingml/2011/main" xmlns:a14="http://schemas.microsoft.com/office/drawing/2010/main" xmlns:m="http://schemas.openxmlformats.org/officeDocument/2006/math" xmlns="" val="1"/>
+              <ma14:wrappingTextBoxFlag xmlns="" xmlns:m="http://schemas.openxmlformats.org/officeDocument/2006/math" xmlns:a14="http://schemas.microsoft.com/office/drawing/2010/main" xmlns:ma14="http://schemas.microsoft.com/office/mac/drawingml/2011/main" val="1"/>
             </a:ext>
           </a:extLst>
         </p:spPr>
@@ -6620,7 +6691,7 @@
           </a:ln>
           <a:extLst>
             <a:ext uri="{C572A759-6A51-4108-AA02-DFA0A04FC94B}">
-              <ma14:wrappingTextBoxFlag xmlns:ma14="http://schemas.microsoft.com/office/mac/drawingml/2011/main" xmlns:a14="http://schemas.microsoft.com/office/drawing/2010/main" xmlns:m="http://schemas.openxmlformats.org/officeDocument/2006/math" xmlns="" val="1"/>
+              <ma14:wrappingTextBoxFlag xmlns="" xmlns:m="http://schemas.openxmlformats.org/officeDocument/2006/math" xmlns:a14="http://schemas.microsoft.com/office/drawing/2010/main" xmlns:ma14="http://schemas.microsoft.com/office/mac/drawingml/2011/main" val="1"/>
             </a:ext>
           </a:extLst>
         </p:spPr>
@@ -6663,7 +6734,7 @@
           </a:ln>
           <a:extLst>
             <a:ext uri="{C572A759-6A51-4108-AA02-DFA0A04FC94B}">
-              <ma14:wrappingTextBoxFlag xmlns:ma14="http://schemas.microsoft.com/office/mac/drawingml/2011/main" xmlns:a14="http://schemas.microsoft.com/office/drawing/2010/main" xmlns:m="http://schemas.openxmlformats.org/officeDocument/2006/math" xmlns="" val="1"/>
+              <ma14:wrappingTextBoxFlag xmlns="" xmlns:m="http://schemas.openxmlformats.org/officeDocument/2006/math" xmlns:a14="http://schemas.microsoft.com/office/drawing/2010/main" xmlns:ma14="http://schemas.microsoft.com/office/mac/drawingml/2011/main" val="1"/>
             </a:ext>
           </a:extLst>
         </p:spPr>
@@ -6736,7 +6807,7 @@
           </a:ln>
           <a:extLst>
             <a:ext uri="{C572A759-6A51-4108-AA02-DFA0A04FC94B}">
-              <ma14:wrappingTextBoxFlag xmlns:ma14="http://schemas.microsoft.com/office/mac/drawingml/2011/main" xmlns:a14="http://schemas.microsoft.com/office/drawing/2010/main" xmlns:m="http://schemas.openxmlformats.org/officeDocument/2006/math" xmlns="" val="1"/>
+              <ma14:wrappingTextBoxFlag xmlns="" xmlns:m="http://schemas.openxmlformats.org/officeDocument/2006/math" xmlns:a14="http://schemas.microsoft.com/office/drawing/2010/main" xmlns:ma14="http://schemas.microsoft.com/office/mac/drawingml/2011/main" val="1"/>
             </a:ext>
           </a:extLst>
         </p:spPr>
@@ -6779,7 +6850,7 @@
           </a:ln>
           <a:extLst>
             <a:ext uri="{C572A759-6A51-4108-AA02-DFA0A04FC94B}">
-              <ma14:wrappingTextBoxFlag xmlns:ma14="http://schemas.microsoft.com/office/mac/drawingml/2011/main" xmlns:a14="http://schemas.microsoft.com/office/drawing/2010/main" xmlns:m="http://schemas.openxmlformats.org/officeDocument/2006/math" xmlns="" val="1"/>
+              <ma14:wrappingTextBoxFlag xmlns="" xmlns:m="http://schemas.openxmlformats.org/officeDocument/2006/math" xmlns:a14="http://schemas.microsoft.com/office/drawing/2010/main" xmlns:ma14="http://schemas.microsoft.com/office/mac/drawingml/2011/main" val="1"/>
             </a:ext>
           </a:extLst>
         </p:spPr>
@@ -6838,7 +6909,7 @@
           </a:fontRef>
         </p:style>
         <p:txBody>
-          <a:bodyPr rtlCol="0" anchor="ctr" wrap="square" lIns="18288" rIns="18288" tIns="18288" bIns="18288"/>
+          <a:bodyPr wrap="square" lIns="18288" tIns="18288" rIns="18288" bIns="18288" rtlCol="0" anchor="ctr"/>
           <a:lstStyle/>
           <a:p>
             <a:pPr algn="l"/>
@@ -6894,7 +6965,7 @@
           </a:fontRef>
         </p:style>
         <p:txBody>
-          <a:bodyPr rtlCol="0" anchor="ctr" wrap="square" lIns="45720" rIns="45720" tIns="18288" bIns="18288"/>
+          <a:bodyPr wrap="square" lIns="45720" tIns="18288" rIns="45720" bIns="18288" rtlCol="0" anchor="ctr"/>
           <a:lstStyle/>
           <a:p>
             <a:pPr algn="ctr"/>
@@ -6972,6 +7043,7 @@
           <a:lstStyle/>
           <a:p>
             <a:pPr algn="ctr"/>
+            <a:endParaRPr/>
           </a:p>
         </p:txBody>
       </p:sp>
@@ -7017,7 +7089,7 @@
           </a:fontRef>
         </p:style>
         <p:txBody>
-          <a:bodyPr rtlCol="0" anchor="ctr" wrap="square" lIns="45720" rIns="45720" tIns="18288" bIns="18288"/>
+          <a:bodyPr wrap="square" lIns="45720" tIns="18288" rIns="45720" bIns="18288" rtlCol="0" anchor="ctr"/>
           <a:lstStyle/>
           <a:p>
             <a:pPr algn="ctr"/>
@@ -7095,6 +7167,7 @@
           <a:lstStyle/>
           <a:p>
             <a:pPr algn="ctr"/>
+            <a:endParaRPr/>
           </a:p>
         </p:txBody>
       </p:sp>
@@ -7140,7 +7213,7 @@
           </a:fontRef>
         </p:style>
         <p:txBody>
-          <a:bodyPr rtlCol="0" anchor="ctr" wrap="square" lIns="45720" rIns="45720" tIns="18288" bIns="18288"/>
+          <a:bodyPr wrap="square" lIns="45720" tIns="18288" rIns="45720" bIns="18288" rtlCol="0" anchor="ctr"/>
           <a:lstStyle/>
           <a:p>
             <a:pPr algn="ctr"/>
@@ -7207,6 +7280,7 @@
           <a:lstStyle/>
           <a:p>
             <a:pPr algn="ctr"/>
+            <a:endParaRPr/>
           </a:p>
         </p:txBody>
       </p:sp>
@@ -7252,7 +7326,7 @@
           </a:fontRef>
         </p:style>
         <p:txBody>
-          <a:bodyPr rtlCol="0" anchor="ctr" wrap="square" lIns="45720" rIns="45720" tIns="18288" bIns="18288"/>
+          <a:bodyPr wrap="square" lIns="45720" tIns="18288" rIns="45720" bIns="18288" rtlCol="0" anchor="ctr"/>
           <a:lstStyle/>
           <a:p>
             <a:pPr algn="ctr"/>
@@ -7330,6 +7404,7 @@
           <a:lstStyle/>
           <a:p>
             <a:pPr algn="ctr"/>
+            <a:endParaRPr/>
           </a:p>
         </p:txBody>
       </p:sp>
@@ -7375,7 +7450,7 @@
           </a:fontRef>
         </p:style>
         <p:txBody>
-          <a:bodyPr rtlCol="0" anchor="ctr" wrap="square" lIns="45720" rIns="45720" tIns="18288" bIns="18288"/>
+          <a:bodyPr wrap="square" lIns="45720" tIns="18288" rIns="45720" bIns="18288" rtlCol="0" anchor="ctr"/>
           <a:lstStyle/>
           <a:p>
             <a:pPr algn="ctr"/>
@@ -7442,6 +7517,7 @@
           <a:lstStyle/>
           <a:p>
             <a:pPr algn="ctr"/>
+            <a:endParaRPr/>
           </a:p>
         </p:txBody>
       </p:sp>
@@ -7487,7 +7563,7 @@
           </a:fontRef>
         </p:style>
         <p:txBody>
-          <a:bodyPr rtlCol="0" anchor="ctr" wrap="square" lIns="45720" rIns="45720" tIns="18288" bIns="18288"/>
+          <a:bodyPr wrap="square" lIns="45720" tIns="18288" rIns="45720" bIns="18288" rtlCol="0" anchor="ctr"/>
           <a:lstStyle/>
           <a:p>
             <a:pPr algn="ctr"/>
@@ -7554,6 +7630,7 @@
           <a:lstStyle/>
           <a:p>
             <a:pPr algn="ctr"/>
+            <a:endParaRPr/>
           </a:p>
         </p:txBody>
       </p:sp>
@@ -7598,7 +7675,7 @@
           </a:fontRef>
         </p:style>
         <p:txBody>
-          <a:bodyPr rtlCol="0" anchor="ctr" wrap="square" lIns="45720" rIns="45720" tIns="18288" bIns="18288"/>
+          <a:bodyPr wrap="square" lIns="45720" tIns="18288" rIns="45720" bIns="18288" rtlCol="0" anchor="ctr"/>
           <a:lstStyle/>
           <a:p>
             <a:pPr algn="ctr"/>
@@ -7666,7 +7743,7 @@
           </a:fontRef>
         </p:style>
         <p:txBody>
-          <a:bodyPr rtlCol="0" anchor="ctr" wrap="square" lIns="45720" rIns="45720" tIns="18288" bIns="18288"/>
+          <a:bodyPr wrap="square" lIns="45720" tIns="18288" rIns="45720" bIns="18288" rtlCol="0" anchor="ctr"/>
           <a:lstStyle/>
           <a:p>
             <a:pPr algn="ctr"/>
@@ -7744,7 +7821,7 @@
           </a:fontRef>
         </p:style>
         <p:txBody>
-          <a:bodyPr rtlCol="0" anchor="ctr" wrap="square" lIns="45720" rIns="45720" tIns="18288" bIns="18288"/>
+          <a:bodyPr wrap="square" lIns="45720" tIns="18288" rIns="45720" bIns="18288" rtlCol="0" anchor="ctr"/>
           <a:lstStyle/>
           <a:p>
             <a:pPr algn="ctr"/>
@@ -7809,7 +7886,7 @@
           </a:fontRef>
         </p:style>
         <p:txBody>
-          <a:bodyPr rtlCol="0" anchor="ctr" wrap="square" tIns="18288" bIns="18288"/>
+          <a:bodyPr wrap="square" tIns="18288" bIns="18288" rtlCol="0" anchor="ctr"/>
           <a:lstStyle/>
           <a:p>
             <a:pPr algn="l"/>
@@ -7852,7 +7929,7 @@
           <a:noFill/>
         </p:spPr>
         <p:txBody>
-          <a:bodyPr wrap="square" lIns="0" rIns="0" tIns="0" bIns="0">
+          <a:bodyPr wrap="square" lIns="0" tIns="0" rIns="0" bIns="0">
             <a:spAutoFit/>
           </a:bodyPr>
           <a:lstStyle/>
@@ -7863,7 +7940,7 @@
               </a:spcAft>
             </a:pPr>
             <a:r>
-              <a:rPr b="1" sz="1000">
+              <a:rPr sz="1000" b="1">
                 <a:solidFill>
                   <a:srgbClr val="123B66"/>
                 </a:solidFill>
@@ -7878,7 +7955,7 @@
               </a:spcAft>
             </a:pPr>
             <a:r>
-              <a:rPr b="0" sz="950">
+              <a:rPr sz="950" b="0">
                 <a:solidFill>
                   <a:srgbClr val="667085"/>
                 </a:solidFill>
@@ -7962,7 +8039,7 @@
           </a:ln>
           <a:extLst>
             <a:ext uri="{C572A759-6A51-4108-AA02-DFA0A04FC94B}">
-              <ma14:wrappingTextBoxFlag xmlns:ma14="http://schemas.microsoft.com/office/mac/drawingml/2011/main" xmlns:a14="http://schemas.microsoft.com/office/drawing/2010/main" xmlns:m="http://schemas.openxmlformats.org/officeDocument/2006/math" xmlns="" val="1"/>
+              <ma14:wrappingTextBoxFlag xmlns="" xmlns:m="http://schemas.openxmlformats.org/officeDocument/2006/math" xmlns:a14="http://schemas.microsoft.com/office/drawing/2010/main" xmlns:ma14="http://schemas.microsoft.com/office/mac/drawingml/2011/main" val="1"/>
             </a:ext>
           </a:extLst>
         </p:spPr>
@@ -8005,7 +8082,7 @@
           </a:ln>
           <a:extLst>
             <a:ext uri="{C572A759-6A51-4108-AA02-DFA0A04FC94B}">
-              <ma14:wrappingTextBoxFlag xmlns:ma14="http://schemas.microsoft.com/office/mac/drawingml/2011/main" xmlns:a14="http://schemas.microsoft.com/office/drawing/2010/main" xmlns:m="http://schemas.openxmlformats.org/officeDocument/2006/math" xmlns="" val="1"/>
+              <ma14:wrappingTextBoxFlag xmlns="" xmlns:m="http://schemas.openxmlformats.org/officeDocument/2006/math" xmlns:a14="http://schemas.microsoft.com/office/drawing/2010/main" xmlns:ma14="http://schemas.microsoft.com/office/mac/drawingml/2011/main" val="1"/>
             </a:ext>
           </a:extLst>
         </p:spPr>
@@ -8081,7 +8158,7 @@
           </a:ln>
           <a:extLst>
             <a:ext uri="{C572A759-6A51-4108-AA02-DFA0A04FC94B}">
-              <ma14:wrappingTextBoxFlag xmlns:ma14="http://schemas.microsoft.com/office/mac/drawingml/2011/main" xmlns:a14="http://schemas.microsoft.com/office/drawing/2010/main" xmlns:m="http://schemas.openxmlformats.org/officeDocument/2006/math" xmlns="" val="1"/>
+              <ma14:wrappingTextBoxFlag xmlns="" xmlns:m="http://schemas.openxmlformats.org/officeDocument/2006/math" xmlns:a14="http://schemas.microsoft.com/office/drawing/2010/main" xmlns:ma14="http://schemas.microsoft.com/office/mac/drawingml/2011/main" val="1"/>
             </a:ext>
           </a:extLst>
         </p:spPr>
@@ -8184,7 +8261,7 @@
           </a:ln>
           <a:extLst>
             <a:ext uri="{C572A759-6A51-4108-AA02-DFA0A04FC94B}">
-              <ma14:wrappingTextBoxFlag xmlns:ma14="http://schemas.microsoft.com/office/mac/drawingml/2011/main" xmlns:a14="http://schemas.microsoft.com/office/drawing/2010/main" xmlns:m="http://schemas.openxmlformats.org/officeDocument/2006/math" xmlns="" val="1"/>
+              <ma14:wrappingTextBoxFlag xmlns="" xmlns:m="http://schemas.openxmlformats.org/officeDocument/2006/math" xmlns:a14="http://schemas.microsoft.com/office/drawing/2010/main" xmlns:ma14="http://schemas.microsoft.com/office/mac/drawingml/2011/main" val="1"/>
             </a:ext>
           </a:extLst>
         </p:spPr>
@@ -8228,7 +8305,7 @@
           </a:ln>
           <a:extLst>
             <a:ext uri="{C572A759-6A51-4108-AA02-DFA0A04FC94B}">
-              <ma14:wrappingTextBoxFlag xmlns:ma14="http://schemas.microsoft.com/office/mac/drawingml/2011/main" xmlns:a14="http://schemas.microsoft.com/office/drawing/2010/main" xmlns:m="http://schemas.openxmlformats.org/officeDocument/2006/math" xmlns="" val="1"/>
+              <ma14:wrappingTextBoxFlag xmlns="" xmlns:m="http://schemas.openxmlformats.org/officeDocument/2006/math" xmlns:a14="http://schemas.microsoft.com/office/drawing/2010/main" xmlns:ma14="http://schemas.microsoft.com/office/mac/drawingml/2011/main" val="1"/>
             </a:ext>
           </a:extLst>
         </p:spPr>
@@ -8272,7 +8349,7 @@
           </a:ln>
           <a:extLst>
             <a:ext uri="{C572A759-6A51-4108-AA02-DFA0A04FC94B}">
-              <ma14:wrappingTextBoxFlag xmlns:ma14="http://schemas.microsoft.com/office/mac/drawingml/2011/main" xmlns:a14="http://schemas.microsoft.com/office/drawing/2010/main" xmlns:m="http://schemas.openxmlformats.org/officeDocument/2006/math" xmlns="" val="1"/>
+              <ma14:wrappingTextBoxFlag xmlns="" xmlns:m="http://schemas.openxmlformats.org/officeDocument/2006/math" xmlns:a14="http://schemas.microsoft.com/office/drawing/2010/main" xmlns:ma14="http://schemas.microsoft.com/office/mac/drawingml/2011/main" val="1"/>
             </a:ext>
           </a:extLst>
         </p:spPr>
@@ -8315,7 +8392,7 @@
           </a:ln>
           <a:extLst>
             <a:ext uri="{C572A759-6A51-4108-AA02-DFA0A04FC94B}">
-              <ma14:wrappingTextBoxFlag xmlns:ma14="http://schemas.microsoft.com/office/mac/drawingml/2011/main" xmlns:a14="http://schemas.microsoft.com/office/drawing/2010/main" xmlns:m="http://schemas.openxmlformats.org/officeDocument/2006/math" xmlns="" val="1"/>
+              <ma14:wrappingTextBoxFlag xmlns="" xmlns:m="http://schemas.openxmlformats.org/officeDocument/2006/math" xmlns:a14="http://schemas.microsoft.com/office/drawing/2010/main" xmlns:ma14="http://schemas.microsoft.com/office/mac/drawingml/2011/main" val="1"/>
             </a:ext>
           </a:extLst>
         </p:spPr>
@@ -8358,7 +8435,7 @@
           </a:ln>
           <a:extLst>
             <a:ext uri="{C572A759-6A51-4108-AA02-DFA0A04FC94B}">
-              <ma14:wrappingTextBoxFlag xmlns:ma14="http://schemas.microsoft.com/office/mac/drawingml/2011/main" xmlns:a14="http://schemas.microsoft.com/office/drawing/2010/main" xmlns:m="http://schemas.openxmlformats.org/officeDocument/2006/math" xmlns="" val="1"/>
+              <ma14:wrappingTextBoxFlag xmlns="" xmlns:m="http://schemas.openxmlformats.org/officeDocument/2006/math" xmlns:a14="http://schemas.microsoft.com/office/drawing/2010/main" xmlns:ma14="http://schemas.microsoft.com/office/mac/drawingml/2011/main" val="1"/>
             </a:ext>
           </a:extLst>
         </p:spPr>
@@ -8401,7 +8478,7 @@
           </a:ln>
           <a:extLst>
             <a:ext uri="{C572A759-6A51-4108-AA02-DFA0A04FC94B}">
-              <ma14:wrappingTextBoxFlag xmlns:ma14="http://schemas.microsoft.com/office/mac/drawingml/2011/main" xmlns:a14="http://schemas.microsoft.com/office/drawing/2010/main" xmlns:m="http://schemas.openxmlformats.org/officeDocument/2006/math" xmlns="" val="1"/>
+              <ma14:wrappingTextBoxFlag xmlns="" xmlns:m="http://schemas.openxmlformats.org/officeDocument/2006/math" xmlns:a14="http://schemas.microsoft.com/office/drawing/2010/main" xmlns:ma14="http://schemas.microsoft.com/office/mac/drawingml/2011/main" val="1"/>
             </a:ext>
           </a:extLst>
         </p:spPr>
@@ -8444,7 +8521,7 @@
           </a:ln>
           <a:extLst>
             <a:ext uri="{C572A759-6A51-4108-AA02-DFA0A04FC94B}">
-              <ma14:wrappingTextBoxFlag xmlns:ma14="http://schemas.microsoft.com/office/mac/drawingml/2011/main" xmlns:a14="http://schemas.microsoft.com/office/drawing/2010/main" xmlns:m="http://schemas.openxmlformats.org/officeDocument/2006/math" xmlns="" val="1"/>
+              <ma14:wrappingTextBoxFlag xmlns="" xmlns:m="http://schemas.openxmlformats.org/officeDocument/2006/math" xmlns:a14="http://schemas.microsoft.com/office/drawing/2010/main" xmlns:ma14="http://schemas.microsoft.com/office/mac/drawingml/2011/main" val="1"/>
             </a:ext>
           </a:extLst>
         </p:spPr>
@@ -8520,7 +8597,7 @@
           </a:ln>
           <a:extLst>
             <a:ext uri="{C572A759-6A51-4108-AA02-DFA0A04FC94B}">
-              <ma14:wrappingTextBoxFlag xmlns:ma14="http://schemas.microsoft.com/office/mac/drawingml/2011/main" xmlns:a14="http://schemas.microsoft.com/office/drawing/2010/main" xmlns:m="http://schemas.openxmlformats.org/officeDocument/2006/math" xmlns="" val="1"/>
+              <ma14:wrappingTextBoxFlag xmlns="" xmlns:m="http://schemas.openxmlformats.org/officeDocument/2006/math" xmlns:a14="http://schemas.microsoft.com/office/drawing/2010/main" xmlns:ma14="http://schemas.microsoft.com/office/mac/drawingml/2011/main" val="1"/>
             </a:ext>
           </a:extLst>
         </p:spPr>
@@ -8595,7 +8672,7 @@
           </a:ln>
           <a:extLst>
             <a:ext uri="{C572A759-6A51-4108-AA02-DFA0A04FC94B}">
-              <ma14:wrappingTextBoxFlag xmlns:ma14="http://schemas.microsoft.com/office/mac/drawingml/2011/main" xmlns:a14="http://schemas.microsoft.com/office/drawing/2010/main" xmlns:m="http://schemas.openxmlformats.org/officeDocument/2006/math" xmlns="" val="1"/>
+              <ma14:wrappingTextBoxFlag xmlns="" xmlns:m="http://schemas.openxmlformats.org/officeDocument/2006/math" xmlns:a14="http://schemas.microsoft.com/office/drawing/2010/main" xmlns:ma14="http://schemas.microsoft.com/office/mac/drawingml/2011/main" val="1"/>
             </a:ext>
           </a:extLst>
         </p:spPr>
@@ -8670,7 +8747,7 @@
           </a:ln>
           <a:extLst>
             <a:ext uri="{C572A759-6A51-4108-AA02-DFA0A04FC94B}">
-              <ma14:wrappingTextBoxFlag xmlns:ma14="http://schemas.microsoft.com/office/mac/drawingml/2011/main" xmlns:a14="http://schemas.microsoft.com/office/drawing/2010/main" xmlns:m="http://schemas.openxmlformats.org/officeDocument/2006/math" xmlns="" val="1"/>
+              <ma14:wrappingTextBoxFlag xmlns="" xmlns:m="http://schemas.openxmlformats.org/officeDocument/2006/math" xmlns:a14="http://schemas.microsoft.com/office/drawing/2010/main" xmlns:ma14="http://schemas.microsoft.com/office/mac/drawingml/2011/main" val="1"/>
             </a:ext>
           </a:extLst>
         </p:spPr>
@@ -8743,7 +8820,7 @@
           </a:ln>
           <a:extLst>
             <a:ext uri="{C572A759-6A51-4108-AA02-DFA0A04FC94B}">
-              <ma14:wrappingTextBoxFlag xmlns:ma14="http://schemas.microsoft.com/office/mac/drawingml/2011/main" xmlns:a14="http://schemas.microsoft.com/office/drawing/2010/main" xmlns:m="http://schemas.openxmlformats.org/officeDocument/2006/math" xmlns="" val="1"/>
+              <ma14:wrappingTextBoxFlag xmlns="" xmlns:m="http://schemas.openxmlformats.org/officeDocument/2006/math" xmlns:a14="http://schemas.microsoft.com/office/drawing/2010/main" xmlns:ma14="http://schemas.microsoft.com/office/mac/drawingml/2011/main" val="1"/>
             </a:ext>
           </a:extLst>
         </p:spPr>
@@ -8786,7 +8863,7 @@
           </a:ln>
           <a:extLst>
             <a:ext uri="{C572A759-6A51-4108-AA02-DFA0A04FC94B}">
-              <ma14:wrappingTextBoxFlag xmlns:ma14="http://schemas.microsoft.com/office/mac/drawingml/2011/main" xmlns:a14="http://schemas.microsoft.com/office/drawing/2010/main" xmlns:m="http://schemas.openxmlformats.org/officeDocument/2006/math" xmlns="" val="1"/>
+              <ma14:wrappingTextBoxFlag xmlns="" xmlns:m="http://schemas.openxmlformats.org/officeDocument/2006/math" xmlns:a14="http://schemas.microsoft.com/office/drawing/2010/main" xmlns:ma14="http://schemas.microsoft.com/office/mac/drawingml/2011/main" val="1"/>
             </a:ext>
           </a:extLst>
         </p:spPr>
@@ -8863,7 +8940,7 @@
           </a:ln>
           <a:extLst>
             <a:ext uri="{C572A759-6A51-4108-AA02-DFA0A04FC94B}">
-              <ma14:wrappingTextBoxFlag xmlns:ma14="http://schemas.microsoft.com/office/mac/drawingml/2011/main" xmlns:a14="http://schemas.microsoft.com/office/drawing/2010/main" xmlns:m="http://schemas.openxmlformats.org/officeDocument/2006/math" xmlns="" val="1"/>
+              <ma14:wrappingTextBoxFlag xmlns="" xmlns:m="http://schemas.openxmlformats.org/officeDocument/2006/math" xmlns:a14="http://schemas.microsoft.com/office/drawing/2010/main" xmlns:ma14="http://schemas.microsoft.com/office/mac/drawingml/2011/main" val="1"/>
             </a:ext>
           </a:extLst>
         </p:spPr>
@@ -8906,7 +8983,7 @@
           </a:ln>
           <a:extLst>
             <a:ext uri="{C572A759-6A51-4108-AA02-DFA0A04FC94B}">
-              <ma14:wrappingTextBoxFlag xmlns:ma14="http://schemas.microsoft.com/office/mac/drawingml/2011/main" xmlns:a14="http://schemas.microsoft.com/office/drawing/2010/main" xmlns:m="http://schemas.openxmlformats.org/officeDocument/2006/math" xmlns="" val="1"/>
+              <ma14:wrappingTextBoxFlag xmlns="" xmlns:m="http://schemas.openxmlformats.org/officeDocument/2006/math" xmlns:a14="http://schemas.microsoft.com/office/drawing/2010/main" xmlns:ma14="http://schemas.microsoft.com/office/mac/drawingml/2011/main" val="1"/>
             </a:ext>
           </a:extLst>
         </p:spPr>
@@ -8985,7 +9062,7 @@
           </a:ln>
           <a:extLst>
             <a:ext uri="{C572A759-6A51-4108-AA02-DFA0A04FC94B}">
-              <ma14:wrappingTextBoxFlag xmlns:ma14="http://schemas.microsoft.com/office/mac/drawingml/2011/main" xmlns:a14="http://schemas.microsoft.com/office/drawing/2010/main" xmlns:m="http://schemas.openxmlformats.org/officeDocument/2006/math" xmlns="" val="1"/>
+              <ma14:wrappingTextBoxFlag xmlns="" xmlns:m="http://schemas.openxmlformats.org/officeDocument/2006/math" xmlns:a14="http://schemas.microsoft.com/office/drawing/2010/main" xmlns:ma14="http://schemas.microsoft.com/office/mac/drawingml/2011/main" val="1"/>
             </a:ext>
           </a:extLst>
         </p:spPr>
@@ -9028,7 +9105,7 @@
           </a:ln>
           <a:extLst>
             <a:ext uri="{C572A759-6A51-4108-AA02-DFA0A04FC94B}">
-              <ma14:wrappingTextBoxFlag xmlns:ma14="http://schemas.microsoft.com/office/mac/drawingml/2011/main" xmlns:a14="http://schemas.microsoft.com/office/drawing/2010/main" xmlns:m="http://schemas.openxmlformats.org/officeDocument/2006/math" xmlns="" val="1"/>
+              <ma14:wrappingTextBoxFlag xmlns="" xmlns:m="http://schemas.openxmlformats.org/officeDocument/2006/math" xmlns:a14="http://schemas.microsoft.com/office/drawing/2010/main" xmlns:ma14="http://schemas.microsoft.com/office/mac/drawingml/2011/main" val="1"/>
             </a:ext>
           </a:extLst>
         </p:spPr>
@@ -9107,7 +9184,7 @@
           </a:ln>
           <a:extLst>
             <a:ext uri="{C572A759-6A51-4108-AA02-DFA0A04FC94B}">
-              <ma14:wrappingTextBoxFlag xmlns:ma14="http://schemas.microsoft.com/office/mac/drawingml/2011/main" xmlns:a14="http://schemas.microsoft.com/office/drawing/2010/main" xmlns:m="http://schemas.openxmlformats.org/officeDocument/2006/math" xmlns="" val="1"/>
+              <ma14:wrappingTextBoxFlag xmlns="" xmlns:m="http://schemas.openxmlformats.org/officeDocument/2006/math" xmlns:a14="http://schemas.microsoft.com/office/drawing/2010/main" xmlns:ma14="http://schemas.microsoft.com/office/mac/drawingml/2011/main" val="1"/>
             </a:ext>
           </a:extLst>
         </p:spPr>
@@ -9150,7 +9227,7 @@
           </a:ln>
           <a:extLst>
             <a:ext uri="{C572A759-6A51-4108-AA02-DFA0A04FC94B}">
-              <ma14:wrappingTextBoxFlag xmlns:ma14="http://schemas.microsoft.com/office/mac/drawingml/2011/main" xmlns:a14="http://schemas.microsoft.com/office/drawing/2010/main" xmlns:m="http://schemas.openxmlformats.org/officeDocument/2006/math" xmlns="" val="1"/>
+              <ma14:wrappingTextBoxFlag xmlns="" xmlns:m="http://schemas.openxmlformats.org/officeDocument/2006/math" xmlns:a14="http://schemas.microsoft.com/office/drawing/2010/main" xmlns:ma14="http://schemas.microsoft.com/office/mac/drawingml/2011/main" val="1"/>
             </a:ext>
           </a:extLst>
         </p:spPr>
@@ -9229,7 +9306,7 @@
           </a:ln>
           <a:extLst>
             <a:ext uri="{C572A759-6A51-4108-AA02-DFA0A04FC94B}">
-              <ma14:wrappingTextBoxFlag xmlns:ma14="http://schemas.microsoft.com/office/mac/drawingml/2011/main" xmlns:a14="http://schemas.microsoft.com/office/drawing/2010/main" xmlns:m="http://schemas.openxmlformats.org/officeDocument/2006/math" xmlns="" val="1"/>
+              <ma14:wrappingTextBoxFlag xmlns="" xmlns:m="http://schemas.openxmlformats.org/officeDocument/2006/math" xmlns:a14="http://schemas.microsoft.com/office/drawing/2010/main" xmlns:ma14="http://schemas.microsoft.com/office/mac/drawingml/2011/main" val="1"/>
             </a:ext>
           </a:extLst>
         </p:spPr>
@@ -9272,7 +9349,7 @@
           </a:ln>
           <a:extLst>
             <a:ext uri="{C572A759-6A51-4108-AA02-DFA0A04FC94B}">
-              <ma14:wrappingTextBoxFlag xmlns:ma14="http://schemas.microsoft.com/office/mac/drawingml/2011/main" xmlns:a14="http://schemas.microsoft.com/office/drawing/2010/main" xmlns:m="http://schemas.openxmlformats.org/officeDocument/2006/math" xmlns="" val="1"/>
+              <ma14:wrappingTextBoxFlag xmlns="" xmlns:m="http://schemas.openxmlformats.org/officeDocument/2006/math" xmlns:a14="http://schemas.microsoft.com/office/drawing/2010/main" xmlns:ma14="http://schemas.microsoft.com/office/mac/drawingml/2011/main" val="1"/>
             </a:ext>
           </a:extLst>
         </p:spPr>
@@ -9347,7 +9424,7 @@
           </a:ln>
           <a:extLst>
             <a:ext uri="{C572A759-6A51-4108-AA02-DFA0A04FC94B}">
-              <ma14:wrappingTextBoxFlag xmlns:ma14="http://schemas.microsoft.com/office/mac/drawingml/2011/main" xmlns:a14="http://schemas.microsoft.com/office/drawing/2010/main" xmlns:m="http://schemas.openxmlformats.org/officeDocument/2006/math" xmlns="" val="1"/>
+              <ma14:wrappingTextBoxFlag xmlns="" xmlns:m="http://schemas.openxmlformats.org/officeDocument/2006/math" xmlns:a14="http://schemas.microsoft.com/office/drawing/2010/main" xmlns:ma14="http://schemas.microsoft.com/office/mac/drawingml/2011/main" val="1"/>
             </a:ext>
           </a:extLst>
         </p:spPr>
@@ -9390,7 +9467,7 @@
           </a:ln>
           <a:extLst>
             <a:ext uri="{C572A759-6A51-4108-AA02-DFA0A04FC94B}">
-              <ma14:wrappingTextBoxFlag xmlns:ma14="http://schemas.microsoft.com/office/mac/drawingml/2011/main" xmlns:a14="http://schemas.microsoft.com/office/drawing/2010/main" xmlns:m="http://schemas.openxmlformats.org/officeDocument/2006/math" xmlns="" val="1"/>
+              <ma14:wrappingTextBoxFlag xmlns="" xmlns:m="http://schemas.openxmlformats.org/officeDocument/2006/math" xmlns:a14="http://schemas.microsoft.com/office/drawing/2010/main" xmlns:ma14="http://schemas.microsoft.com/office/mac/drawingml/2011/main" val="1"/>
             </a:ext>
           </a:extLst>
         </p:spPr>
@@ -9488,7 +9565,7 @@
           </a:ln>
           <a:extLst>
             <a:ext uri="{C572A759-6A51-4108-AA02-DFA0A04FC94B}">
-              <ma14:wrappingTextBoxFlag xmlns:ma14="http://schemas.microsoft.com/office/mac/drawingml/2011/main" xmlns:a14="http://schemas.microsoft.com/office/drawing/2010/main" xmlns:m="http://schemas.openxmlformats.org/officeDocument/2006/math" xmlns="" val="1"/>
+              <ma14:wrappingTextBoxFlag xmlns="" xmlns:m="http://schemas.openxmlformats.org/officeDocument/2006/math" xmlns:a14="http://schemas.microsoft.com/office/drawing/2010/main" xmlns:ma14="http://schemas.microsoft.com/office/mac/drawingml/2011/main" val="1"/>
             </a:ext>
           </a:extLst>
         </p:spPr>
@@ -9531,7 +9608,7 @@
           </a:ln>
           <a:extLst>
             <a:ext uri="{C572A759-6A51-4108-AA02-DFA0A04FC94B}">
-              <ma14:wrappingTextBoxFlag xmlns:ma14="http://schemas.microsoft.com/office/mac/drawingml/2011/main" xmlns:a14="http://schemas.microsoft.com/office/drawing/2010/main" xmlns:m="http://schemas.openxmlformats.org/officeDocument/2006/math" xmlns="" val="1"/>
+              <ma14:wrappingTextBoxFlag xmlns="" xmlns:m="http://schemas.openxmlformats.org/officeDocument/2006/math" xmlns:a14="http://schemas.microsoft.com/office/drawing/2010/main" xmlns:ma14="http://schemas.microsoft.com/office/mac/drawingml/2011/main" val="1"/>
             </a:ext>
           </a:extLst>
         </p:spPr>
@@ -9607,7 +9684,7 @@
           </a:ln>
           <a:extLst>
             <a:ext uri="{C572A759-6A51-4108-AA02-DFA0A04FC94B}">
-              <ma14:wrappingTextBoxFlag xmlns:ma14="http://schemas.microsoft.com/office/mac/drawingml/2011/main" xmlns:a14="http://schemas.microsoft.com/office/drawing/2010/main" xmlns:m="http://schemas.openxmlformats.org/officeDocument/2006/math" xmlns="" val="1"/>
+              <ma14:wrappingTextBoxFlag xmlns="" xmlns:m="http://schemas.openxmlformats.org/officeDocument/2006/math" xmlns:a14="http://schemas.microsoft.com/office/drawing/2010/main" xmlns:ma14="http://schemas.microsoft.com/office/mac/drawingml/2011/main" val="1"/>
             </a:ext>
           </a:extLst>
         </p:spPr>
@@ -10163,7 +10240,7 @@
           </a:ln>
           <a:extLst>
             <a:ext uri="{C572A759-6A51-4108-AA02-DFA0A04FC94B}">
-              <ma14:wrappingTextBoxFlag xmlns:ma14="http://schemas.microsoft.com/office/mac/drawingml/2011/main" xmlns:a14="http://schemas.microsoft.com/office/drawing/2010/main" xmlns:m="http://schemas.openxmlformats.org/officeDocument/2006/math" xmlns="" val="1"/>
+              <ma14:wrappingTextBoxFlag xmlns="" xmlns:m="http://schemas.openxmlformats.org/officeDocument/2006/math" xmlns:a14="http://schemas.microsoft.com/office/drawing/2010/main" xmlns:ma14="http://schemas.microsoft.com/office/mac/drawingml/2011/main" val="1"/>
             </a:ext>
           </a:extLst>
         </p:spPr>
@@ -10206,7 +10283,7 @@
           </a:ln>
           <a:extLst>
             <a:ext uri="{C572A759-6A51-4108-AA02-DFA0A04FC94B}">
-              <ma14:wrappingTextBoxFlag xmlns:ma14="http://schemas.microsoft.com/office/mac/drawingml/2011/main" xmlns:a14="http://schemas.microsoft.com/office/drawing/2010/main" xmlns:m="http://schemas.openxmlformats.org/officeDocument/2006/math" xmlns="" val="1"/>
+              <ma14:wrappingTextBoxFlag xmlns="" xmlns:m="http://schemas.openxmlformats.org/officeDocument/2006/math" xmlns:a14="http://schemas.microsoft.com/office/drawing/2010/main" xmlns:ma14="http://schemas.microsoft.com/office/mac/drawingml/2011/main" val="1"/>
             </a:ext>
           </a:extLst>
         </p:spPr>
@@ -10259,7 +10336,7 @@
           </a:ln>
           <a:extLst>
             <a:ext uri="{C572A759-6A51-4108-AA02-DFA0A04FC94B}">
-              <ma14:wrappingTextBoxFlag xmlns:ma14="http://schemas.microsoft.com/office/mac/drawingml/2011/main" xmlns:a14="http://schemas.microsoft.com/office/drawing/2010/main" xmlns:m="http://schemas.openxmlformats.org/officeDocument/2006/math" xmlns="" val="1"/>
+              <ma14:wrappingTextBoxFlag xmlns="" xmlns:m="http://schemas.openxmlformats.org/officeDocument/2006/math" xmlns:a14="http://schemas.microsoft.com/office/drawing/2010/main" xmlns:ma14="http://schemas.microsoft.com/office/mac/drawingml/2011/main" val="1"/>
             </a:ext>
           </a:extLst>
         </p:spPr>
@@ -10331,7 +10408,7 @@
           </a:ln>
           <a:extLst>
             <a:ext uri="{C572A759-6A51-4108-AA02-DFA0A04FC94B}">
-              <ma14:wrappingTextBoxFlag xmlns:ma14="http://schemas.microsoft.com/office/mac/drawingml/2011/main" xmlns:a14="http://schemas.microsoft.com/office/drawing/2010/main" xmlns:m="http://schemas.openxmlformats.org/officeDocument/2006/math" xmlns="" val="1"/>
+              <ma14:wrappingTextBoxFlag xmlns="" xmlns:m="http://schemas.openxmlformats.org/officeDocument/2006/math" xmlns:a14="http://schemas.microsoft.com/office/drawing/2010/main" xmlns:ma14="http://schemas.microsoft.com/office/mac/drawingml/2011/main" val="1"/>
             </a:ext>
           </a:extLst>
         </p:spPr>
@@ -10374,7 +10451,7 @@
           </a:ln>
           <a:extLst>
             <a:ext uri="{C572A759-6A51-4108-AA02-DFA0A04FC94B}">
-              <ma14:wrappingTextBoxFlag xmlns:ma14="http://schemas.microsoft.com/office/mac/drawingml/2011/main" xmlns:a14="http://schemas.microsoft.com/office/drawing/2010/main" xmlns:m="http://schemas.openxmlformats.org/officeDocument/2006/math" xmlns="" val="1"/>
+              <ma14:wrappingTextBoxFlag xmlns="" xmlns:m="http://schemas.openxmlformats.org/officeDocument/2006/math" xmlns:a14="http://schemas.microsoft.com/office/drawing/2010/main" xmlns:ma14="http://schemas.microsoft.com/office/mac/drawingml/2011/main" val="1"/>
             </a:ext>
           </a:extLst>
         </p:spPr>

</xml_diff>